<commit_message>
fix(deck): correct unsupported compliance statements
Legal review of the restructured deck found six statements that overstate what exists, so the deck now says less and says it accurately:

- Malawi DPA 2017 -> DPA 2024 (operative act is Act No. 3 of 2024; 2017 is stale).

- SOC 2 readiness dropped as a present-tense capability: it is an unchecked task and a target, never an attestation. Now 'SOC 2 planned, not certified'.

- GDPR opinion dropped: the only artefact is a budget line to buy one.

- 'Governance gates operating under audit' -> 'live with tamper-evident audit trail'; no external audit engagement exists.

- 'Human approval gates ratified' -> 'enforced in code' (tiers 0-4 enforced pre-execution in tool_runner.py; 'ratified' was self-ratification).

- 'agent registry in production' -> 'running this company internally'; nothing is in production without a client.

Gate unchanged: V01-V12 PASS, V13 skipped, exit 2 INCOMPLETE (no verified claims, no QA verdict). 11 slides.
</commit_message>
<xml_diff>
--- a/static/brand/templates/pitch-deck.pptx
+++ b/static/brand/templates/pitch-deck.pptx
@@ -3770,7 +3770,7 @@
                 </a:solidFill>
                 <a:latin typeface="Arial"/>
               </a:rPr>
-              <a:t>Compliance — Malawi DPA 2017, GDPR, SOC 2 readiness</a:t>
+              <a:t>Compliance — DPA 2024 alignment, GDPR opinion, SOC 2 prep</a:t>
             </a:r>
           </a:p>
           <a:p>
@@ -3923,7 +3923,7 @@
                 </a:solidFill>
                 <a:latin typeface="Arial"/>
               </a:rPr>
-              <a:t>Governance gates operating under audit</a:t>
+              <a:t>Governance gates live with tamper-evident audit trail</a:t>
             </a:r>
           </a:p>
           <a:p>
@@ -4437,7 +4437,7 @@
                 </a:solidFill>
                 <a:latin typeface="Arial"/>
               </a:rPr>
-              <a:t>Malawi DPA 2017 controls, GDPR opinion, SOC 2 readiness</a:t>
+              <a:t>Built to DPA 2024 and GDPR-grade handling; SOC 2 planned, not certified</a:t>
             </a:r>
           </a:p>
         </p:txBody>
@@ -8203,7 +8203,7 @@
                 </a:solidFill>
                 <a:latin typeface="Arial"/>
               </a:rPr>
-              <a:t>•  Platform shipped; agent registry in production</a:t>
+              <a:t>•  Platform built, running this company internally</a:t>
             </a:r>
           </a:p>
           <a:p>
@@ -8247,7 +8247,7 @@
                 </a:solidFill>
                 <a:latin typeface="Arial"/>
               </a:rPr>
-              <a:t>•  Human approval gates ratified</a:t>
+              <a:t>•  Human approval gates enforced in code</a:t>
             </a:r>
           </a:p>
           <a:p>

</xml_diff>